<commit_message>
Topic 2 IEP: formulas and worked steps in bell work, graphs that plot each move
- Bell work (deck slides, online pages, answer keys): a formula under every
  question and numbered steps with the answer.
- Up/down (and right) moves are drawn as black points, dashed arrows marked
  "+5 up" / "-4 down", the moved points, then the new line, one click each.
- mc.js: accom.add merges extra fields into a question; make_pptx: line "dot".

Co-Authored-By: Claude Opus 5.5 (1M context) <noreply@anthropic.com>
</commit_message>
<xml_diff>
--- a/IEP/t2-lesson1-bellwork-IEP-ANSWER-KEY.pptx
+++ b/IEP/t2-lesson1-bellwork-IEP-ANSWER-KEY.pptx
@@ -1369,7 +1369,7 @@
         <p:spPr>
           <a:xfrm>
             <a:off x="685800" y="1707642"/>
-            <a:ext cx="2164019" cy="1024128"/>
+            <a:ext cx="2164019" cy="1847088"/>
           </a:xfrm>
           <a:prstGeom prst="rect">
             <a:avLst/>
@@ -1413,7 +1413,7 @@
         <p:spPr>
           <a:xfrm>
             <a:off x="2849819" y="1707642"/>
-            <a:ext cx="4328038" cy="1024128"/>
+            <a:ext cx="4328038" cy="1847088"/>
           </a:xfrm>
           <a:prstGeom prst="rect">
             <a:avLst/>
@@ -1457,7 +1457,7 @@
         <p:spPr>
           <a:xfrm>
             <a:off x="7177857" y="1707642"/>
-            <a:ext cx="4328038" cy="1024128"/>
+            <a:ext cx="4328038" cy="1847088"/>
           </a:xfrm>
           <a:prstGeom prst="rect">
             <a:avLst/>
@@ -1505,7 +1505,7 @@
                 <a:latin typeface="Segoe UI"/>
                 <a:cs typeface="Segoe UI"/>
               </a:rPr>
-              <a:t xml:space="preserve">Slope = (11 − 2) ÷ (4 − 1) = 9 ÷ 3 = 3.</a:t>
+              <a:t xml:space="preserve">1. Label the points: (x₁, y₁) = (1, 2) and (x₂, y₂) = (4, 11). 2. Subtract the y-values: 11 − 2 = 9. Subtract the x-values: 4 − 1 = 3. 3. Divide: 9 ÷ 3 = 3.</a:t>
             </a:r>
             <a:endParaRPr lang="en-US" sz="1800" dirty="0"/>
           </a:p>
@@ -1519,7 +1519,7 @@
         </p:nvCxnSpPr>
         <p:spPr>
           <a:xfrm>
-            <a:off x="685800" y="2731770"/>
+            <a:off x="685800" y="3554730"/>
             <a:ext cx="10820095" cy="0"/>
           </a:xfrm>
           <a:prstGeom prst="line">
@@ -1540,8 +1540,8 @@
         </p:nvSpPr>
         <p:spPr>
           <a:xfrm>
-            <a:off x="685800" y="2731770"/>
-            <a:ext cx="2164019" cy="1024128"/>
+            <a:off x="685800" y="3554730"/>
+            <a:ext cx="2164019" cy="1298448"/>
           </a:xfrm>
           <a:prstGeom prst="rect">
             <a:avLst/>
@@ -1584,8 +1584,8 @@
         </p:nvSpPr>
         <p:spPr>
           <a:xfrm>
-            <a:off x="2849819" y="2731770"/>
-            <a:ext cx="4328038" cy="1024128"/>
+            <a:off x="2849819" y="3554730"/>
+            <a:ext cx="4328038" cy="1298448"/>
           </a:xfrm>
           <a:prstGeom prst="rect">
             <a:avLst/>
@@ -1628,8 +1628,8 @@
         </p:nvSpPr>
         <p:spPr>
           <a:xfrm>
-            <a:off x="7177857" y="2731770"/>
-            <a:ext cx="4328038" cy="1024128"/>
+            <a:off x="7177857" y="3554730"/>
+            <a:ext cx="4328038" cy="1298448"/>
           </a:xfrm>
           <a:prstGeom prst="rect">
             <a:avLst/>
@@ -1677,7 +1677,7 @@
                 <a:latin typeface="Segoe UI"/>
                 <a:cs typeface="Segoe UI"/>
               </a:rPr>
-              <a:t xml:space="preserve">In y = mx + b, the y-intercept is (0, b), so it is (0, −7).</a:t>
+              <a:t xml:space="preserve">1. Match y = 3x − 7 to y = mx + b: m = 3 and b = −7. 2. The y-intercept is (0, b) = (0, −7).</a:t>
             </a:r>
             <a:endParaRPr lang="en-US" sz="1800" dirty="0"/>
           </a:p>
@@ -1691,7 +1691,7 @@
         </p:nvCxnSpPr>
         <p:spPr>
           <a:xfrm>
-            <a:off x="685800" y="3755898"/>
+            <a:off x="685800" y="4853178"/>
             <a:ext cx="10820095" cy="0"/>
           </a:xfrm>
           <a:prstGeom prst="line">
@@ -2016,7 +2016,7 @@
         <p:spPr>
           <a:xfrm>
             <a:off x="685800" y="1707642"/>
-            <a:ext cx="2164019" cy="749808"/>
+            <a:ext cx="2164019" cy="1298448"/>
           </a:xfrm>
           <a:prstGeom prst="rect">
             <a:avLst/>
@@ -2060,7 +2060,7 @@
         <p:spPr>
           <a:xfrm>
             <a:off x="2849819" y="1707642"/>
-            <a:ext cx="4328038" cy="749808"/>
+            <a:ext cx="4328038" cy="1298448"/>
           </a:xfrm>
           <a:prstGeom prst="rect">
             <a:avLst/>
@@ -2104,7 +2104,7 @@
         <p:spPr>
           <a:xfrm>
             <a:off x="7177857" y="1707642"/>
-            <a:ext cx="4328038" cy="749808"/>
+            <a:ext cx="4328038" cy="1298448"/>
           </a:xfrm>
           <a:prstGeom prst="rect">
             <a:avLst/>
@@ -2152,7 +2152,7 @@
                 <a:latin typeface="Segoe UI"/>
                 <a:cs typeface="Segoe UI"/>
               </a:rPr>
-              <a:t xml:space="preserve">2(−3) + 1 = −6 + 1 = −5.</a:t>
+              <a:t xml:space="preserve">1. Replace x with (−3): f(−3) = 2(−3) + 1. 2. Multiply: 2(−3) = −6. 3. Add: −6 + 1 = −5.</a:t>
             </a:r>
             <a:endParaRPr lang="en-US" sz="1800" dirty="0"/>
           </a:p>
@@ -2166,7 +2166,7 @@
         </p:nvCxnSpPr>
         <p:spPr>
           <a:xfrm>
-            <a:off x="685800" y="2457450"/>
+            <a:off x="685800" y="3006090"/>
             <a:ext cx="10820095" cy="0"/>
           </a:xfrm>
           <a:prstGeom prst="line">
@@ -2187,8 +2187,8 @@
         </p:nvSpPr>
         <p:spPr>
           <a:xfrm>
-            <a:off x="685800" y="2457450"/>
-            <a:ext cx="2164019" cy="1024128"/>
+            <a:off x="685800" y="3006090"/>
+            <a:ext cx="2164019" cy="1298448"/>
           </a:xfrm>
           <a:prstGeom prst="rect">
             <a:avLst/>
@@ -2231,8 +2231,8 @@
         </p:nvSpPr>
         <p:spPr>
           <a:xfrm>
-            <a:off x="2849819" y="2457450"/>
-            <a:ext cx="4328038" cy="1024128"/>
+            <a:off x="2849819" y="3006090"/>
+            <a:ext cx="4328038" cy="1298448"/>
           </a:xfrm>
           <a:prstGeom prst="rect">
             <a:avLst/>
@@ -2275,8 +2275,8 @@
         </p:nvSpPr>
         <p:spPr>
           <a:xfrm>
-            <a:off x="7177857" y="2457450"/>
-            <a:ext cx="4328038" cy="1024128"/>
+            <a:off x="7177857" y="3006090"/>
+            <a:ext cx="4328038" cy="1298448"/>
           </a:xfrm>
           <a:prstGeom prst="rect">
             <a:avLst/>
@@ -2324,7 +2324,7 @@
                 <a:latin typeface="Segoe UI"/>
                 <a:cs typeface="Segoe UI"/>
               </a:rPr>
-              <a:t xml:space="preserve">Parallel lines have the same slope. Only y = 3x − 5 has slope 3.</a:t>
+              <a:t xml:space="preserve">1. The slope of y = 3x + 1 is 3, the number with x. 2. Find the choice with slope 3: y = 3x − 5.</a:t>
             </a:r>
             <a:endParaRPr lang="en-US" sz="1800" dirty="0"/>
           </a:p>
@@ -2338,7 +2338,7 @@
         </p:nvCxnSpPr>
         <p:spPr>
           <a:xfrm>
-            <a:off x="685800" y="3481578"/>
+            <a:off x="685800" y="4304538"/>
             <a:ext cx="10820095" cy="0"/>
           </a:xfrm>
           <a:prstGeom prst="line">
@@ -2663,7 +2663,7 @@
         <p:spPr>
           <a:xfrm>
             <a:off x="685800" y="1707642"/>
-            <a:ext cx="2164019" cy="1024128"/>
+            <a:ext cx="2164019" cy="1298448"/>
           </a:xfrm>
           <a:prstGeom prst="rect">
             <a:avLst/>
@@ -2717,7 +2717,7 @@
         <p:spPr>
           <a:xfrm>
             <a:off x="2849819" y="1707642"/>
-            <a:ext cx="4328038" cy="1024128"/>
+            <a:ext cx="4328038" cy="1298448"/>
           </a:xfrm>
           <a:prstGeom prst="rect">
             <a:avLst/>
@@ -2761,7 +2761,7 @@
         <p:spPr>
           <a:xfrm>
             <a:off x="7177857" y="1707642"/>
-            <a:ext cx="4328038" cy="1024128"/>
+            <a:ext cx="4328038" cy="1298448"/>
           </a:xfrm>
           <a:prstGeom prst="rect">
             <a:avLst/>
@@ -2809,7 +2809,7 @@
                 <a:latin typeface="Segoe UI"/>
                 <a:cs typeface="Segoe UI"/>
               </a:rPr>
-              <a:t xml:space="preserve">A vertical translation adds to the output: g(x) = f(x) + 4 = x + 4.</a:t>
+              <a:t xml:space="preserve">1. Up 4 means add 4 to every output: g(x) = f(x) + 4. 2. Replace f(x) with x: g(x) = x + 4.</a:t>
             </a:r>
             <a:endParaRPr lang="en-US" sz="1800" dirty="0"/>
           </a:p>
@@ -2823,7 +2823,7 @@
         </p:nvCxnSpPr>
         <p:spPr>
           <a:xfrm>
-            <a:off x="685800" y="2731770"/>
+            <a:off x="685800" y="3006090"/>
             <a:ext cx="10820095" cy="0"/>
           </a:xfrm>
           <a:prstGeom prst="line">
@@ -2844,8 +2844,8 @@
         </p:nvSpPr>
         <p:spPr>
           <a:xfrm>
-            <a:off x="685800" y="2731770"/>
-            <a:ext cx="2164019" cy="1024128"/>
+            <a:off x="685800" y="3006090"/>
+            <a:ext cx="2164019" cy="1298448"/>
           </a:xfrm>
           <a:prstGeom prst="rect">
             <a:avLst/>
@@ -2898,8 +2898,8 @@
         </p:nvSpPr>
         <p:spPr>
           <a:xfrm>
-            <a:off x="2849819" y="2731770"/>
-            <a:ext cx="4328038" cy="1024128"/>
+            <a:off x="2849819" y="3006090"/>
+            <a:ext cx="4328038" cy="1298448"/>
           </a:xfrm>
           <a:prstGeom prst="rect">
             <a:avLst/>
@@ -2942,8 +2942,8 @@
         </p:nvSpPr>
         <p:spPr>
           <a:xfrm>
-            <a:off x="7177857" y="2731770"/>
-            <a:ext cx="4328038" cy="1024128"/>
+            <a:off x="7177857" y="3006090"/>
+            <a:ext cx="4328038" cy="1298448"/>
           </a:xfrm>
           <a:prstGeom prst="rect">
             <a:avLst/>
@@ -2991,7 +2991,7 @@
                 <a:latin typeface="Segoe UI"/>
                 <a:cs typeface="Segoe UI"/>
               </a:rPr>
-              <a:t xml:space="preserve">A vertical translation changes only y: 5 − 3 = 2, so (2, 2).</a:t>
+              <a:t xml:space="preserve">1. x stays the same: x = 2. 2. Down 3, so subtract 3 from y: 5 − 3 = 2. 3. The new point is (2, 2).</a:t>
             </a:r>
             <a:endParaRPr lang="en-US" sz="1800" dirty="0"/>
           </a:p>
@@ -3005,7 +3005,7 @@
         </p:nvCxnSpPr>
         <p:spPr>
           <a:xfrm>
-            <a:off x="685800" y="3755898"/>
+            <a:off x="685800" y="4304538"/>
             <a:ext cx="10820095" cy="0"/>
           </a:xfrm>
           <a:prstGeom prst="line">
@@ -3476,7 +3476,7 @@
                 <a:latin typeface="Segoe UI"/>
                 <a:cs typeface="Segoe UI"/>
               </a:rPr>
-              <a:t xml:space="preserve">A vertical translation does not change the slope. g(x) = 2x + 5 still has slope 2.</a:t>
+              <a:t xml:space="preserve">1. g(x) = 2x − 1 + 6 = 2x + 5. 2. The number with x is still 2, so the slope is 2.</a:t>
             </a:r>
             <a:endParaRPr lang="en-US" sz="1800" dirty="0"/>
           </a:p>
@@ -3512,7 +3512,7 @@
         <p:spPr>
           <a:xfrm>
             <a:off x="685800" y="3006090"/>
-            <a:ext cx="2164019" cy="1298448"/>
+            <a:ext cx="2164019" cy="1572768"/>
           </a:xfrm>
           <a:prstGeom prst="rect">
             <a:avLst/>
@@ -3566,7 +3566,7 @@
         <p:spPr>
           <a:xfrm>
             <a:off x="2849819" y="3006090"/>
-            <a:ext cx="4328038" cy="1298448"/>
+            <a:ext cx="4328038" cy="1572768"/>
           </a:xfrm>
           <a:prstGeom prst="rect">
             <a:avLst/>
@@ -3610,7 +3610,7 @@
         <p:spPr>
           <a:xfrm>
             <a:off x="7177857" y="3006090"/>
-            <a:ext cx="4328038" cy="1298448"/>
+            <a:ext cx="4328038" cy="1572768"/>
           </a:xfrm>
           <a:prstGeom prst="rect">
             <a:avLst/>
@@ -3658,7 +3658,7 @@
                 <a:latin typeface="Segoe UI"/>
                 <a:cs typeface="Segoe UI"/>
               </a:rPr>
-              <a:t xml:space="preserve">g(x) = 2x − 1 + 6 = 2x + 5, so the y-intercept moves from (0, −1) up 6 to (0, 5).</a:t>
+              <a:t xml:space="preserve">1. g(x) = 2x − 1 + 6. 2. Combine: −1 + 6 = 5, so g(x) = 2x + 5. 3. b = 5, so the y-intercept is (0, 5): (0, −1) moved up 6.</a:t>
             </a:r>
             <a:endParaRPr lang="en-US" sz="1800" dirty="0"/>
           </a:p>
@@ -3672,7 +3672,7 @@
         </p:nvCxnSpPr>
         <p:spPr>
           <a:xfrm>
-            <a:off x="685800" y="4304538"/>
+            <a:off x="685800" y="4578858"/>
             <a:ext cx="10820095" cy="0"/>
           </a:xfrm>
           <a:prstGeom prst="line">
@@ -4143,7 +4143,7 @@
                 <a:latin typeface="Segoe UI"/>
                 <a:cs typeface="Segoe UI"/>
               </a:rPr>
-              <a:t xml:space="preserve">g(x) = 3x. A vertical dilation by 3 multiplies the slope of f(x) = x by 3.</a:t>
+              <a:t xml:space="preserve">1. Replace f(x) with x: g(x) = 3x. 2. The number with x is 3, so the slope is 3.</a:t>
             </a:r>
             <a:endParaRPr lang="en-US" sz="1800" dirty="0"/>
           </a:p>
@@ -4179,7 +4179,7 @@
         <p:spPr>
           <a:xfrm>
             <a:off x="685800" y="3006090"/>
-            <a:ext cx="2164019" cy="1572768"/>
+            <a:ext cx="2164019" cy="1847088"/>
           </a:xfrm>
           <a:prstGeom prst="rect">
             <a:avLst/>
@@ -4233,7 +4233,7 @@
         <p:spPr>
           <a:xfrm>
             <a:off x="2849819" y="3006090"/>
-            <a:ext cx="4328038" cy="1572768"/>
+            <a:ext cx="4328038" cy="1847088"/>
           </a:xfrm>
           <a:prstGeom prst="rect">
             <a:avLst/>
@@ -4277,7 +4277,7 @@
         <p:spPr>
           <a:xfrm>
             <a:off x="7177857" y="3006090"/>
-            <a:ext cx="4328038" cy="1572768"/>
+            <a:ext cx="4328038" cy="1847088"/>
           </a:xfrm>
           <a:prstGeom prst="rect">
             <a:avLst/>
@@ -4325,7 +4325,7 @@
                 <a:latin typeface="Segoe UI"/>
                 <a:cs typeface="Segoe UI"/>
               </a:rPr>
-              <a:t xml:space="preserve">The 2 stretches the graph and the negative sign reflects it across the x-axis.</a:t>
+              <a:t xml:space="preserve">1. a = −2. The size, 2, is more than 1: stretched by 2. 2. The sign is negative: reflected (flipped) across the x-axis.</a:t>
             </a:r>
             <a:endParaRPr lang="en-US" sz="1800" dirty="0"/>
           </a:p>
@@ -4339,7 +4339,7 @@
         </p:nvCxnSpPr>
         <p:spPr>
           <a:xfrm>
-            <a:off x="685800" y="4578858"/>
+            <a:off x="685800" y="4853178"/>
             <a:ext cx="10820095" cy="0"/>
           </a:xfrm>
           <a:prstGeom prst="line">
@@ -4810,7 +4810,7 @@
                 <a:latin typeface="Segoe UI"/>
                 <a:cs typeface="Segoe UI"/>
               </a:rPr>
-              <a:t xml:space="preserve">Multiplying by a number between 0 and 1 compresses the graph toward the x-axis.</a:t>
+              <a:t xml:space="preserve">1. Look for a number between 0 and 1 in front of f(x). 2. ½ is between 0 and 1, so g(x) = ½f(x) compresses.</a:t>
             </a:r>
             <a:endParaRPr lang="en-US" sz="1800" dirty="0"/>
           </a:p>
@@ -4992,7 +4992,7 @@
                 <a:latin typeface="Segoe UI"/>
                 <a:cs typeface="Segoe UI"/>
               </a:rPr>
-              <a:t xml:space="preserve">g(x) = 2x − 5. The dilation keeps (0, 0) fixed, then the graph moves down 5.</a:t>
+              <a:t xml:space="preserve">1. Replace f(x) with x: g(x) = 2x − 5. 2. d = −5, so the y-intercept is (0, −5).</a:t>
             </a:r>
             <a:endParaRPr lang="en-US" sz="1800" dirty="0"/>
           </a:p>

</xml_diff>

<commit_message>
Topic 2: test-style practice, SE page labels and essential stars on the slides with answers
- Bell work, homework and quizzes get items written like the End of Topic 2
  Assessment (same wording, graphs, tables, F-J choice letters) with new numbers;
  IEP pages keep two of them per homework/quiz, with worked bell-work steps.
- Publisher slides with answers (L1-L4): "SE p. N" Student Edition label on each
  content slide; "★ Essential" on activities starred in the 150-day pacing guide
  (L4 is "omit" there, so no stars); lettered answers moved under their own letters.
- Pacing calendar marks the starred activities.

Co-Authored-By: Claude Opus 5.5 (1M context) <noreply@anthropic.com>
</commit_message>
<xml_diff>
--- a/IEP/t2-lesson1-bellwork-IEP-ANSWER-KEY.pptx
+++ b/IEP/t2-lesson1-bellwork-IEP-ANSWER-KEY.pptx
@@ -2188,7 +2188,7 @@
         <p:spPr>
           <a:xfrm>
             <a:off x="685800" y="3006090"/>
-            <a:ext cx="2164019" cy="1298448"/>
+            <a:ext cx="2164019" cy="1572768"/>
           </a:xfrm>
           <a:prstGeom prst="rect">
             <a:avLst/>
@@ -2232,7 +2232,7 @@
         <p:spPr>
           <a:xfrm>
             <a:off x="2849819" y="3006090"/>
-            <a:ext cx="4328038" cy="1298448"/>
+            <a:ext cx="4328038" cy="1572768"/>
           </a:xfrm>
           <a:prstGeom prst="rect">
             <a:avLst/>
@@ -2261,7 +2261,7 @@
                 <a:latin typeface="Segoe UI"/>
                 <a:cs typeface="Segoe UI"/>
               </a:rPr>
-              <a:t xml:space="preserve">Which line is parallel to y = 3x + 1?</a:t>
+              <a:t xml:space="preserve">Which equation in slope-intercept form is parallel to y = 3x + 1 and passes through (1, 5)?</a:t>
             </a:r>
             <a:endParaRPr lang="en-US" sz="1800" dirty="0"/>
           </a:p>
@@ -2276,7 +2276,7 @@
         <p:spPr>
           <a:xfrm>
             <a:off x="7177857" y="3006090"/>
-            <a:ext cx="4328038" cy="1298448"/>
+            <a:ext cx="4328038" cy="1572768"/>
           </a:xfrm>
           <a:prstGeom prst="rect">
             <a:avLst/>
@@ -2305,7 +2305,7 @@
                 <a:latin typeface="Segoe UI"/>
                 <a:cs typeface="Segoe UI"/>
               </a:rPr>
-              <a:t xml:space="preserve">y = 3x − 5</a:t>
+              <a:t xml:space="preserve">y = 3x + 2</a:t>
             </a:r>
             <a:br>
               <a:rPr lang="en-US" sz="1800" dirty="0">
@@ -2324,7 +2324,7 @@
                 <a:latin typeface="Segoe UI"/>
                 <a:cs typeface="Segoe UI"/>
               </a:rPr>
-              <a:t xml:space="preserve">1. The slope of y = 3x + 1 is 3, the number with x. 2. Find the choice with slope 3: y = 3x − 5.</a:t>
+              <a:t xml:space="preserve">1. Parallel to y = 3x + 1 means the same slope: m = 3. 2. Put in the point (1, 5): 5 = 3(1) + b. 3. 5 = 3 + b, so b = 2: y = 3x + 2.</a:t>
             </a:r>
             <a:endParaRPr lang="en-US" sz="1800" dirty="0"/>
           </a:p>
@@ -2338,7 +2338,7 @@
         </p:nvCxnSpPr>
         <p:spPr>
           <a:xfrm>
-            <a:off x="685800" y="4304538"/>
+            <a:off x="685800" y="4578858"/>
             <a:ext cx="10820095" cy="0"/>
           </a:xfrm>
           <a:prstGeom prst="line">
@@ -3595,7 +3595,7 @@
                 <a:latin typeface="Segoe UI"/>
                 <a:cs typeface="Segoe UI"/>
               </a:rPr>
-              <a:t xml:space="preserve">f(x) = 2x − 1. What is the y-intercept of g(x) = f(x) + 6?</a:t>
+              <a:t xml:space="preserve">The graph of f(x) = x is transformed to make g(x) = x − 2. Which describes the transformation?</a:t>
             </a:r>
             <a:endParaRPr lang="en-US" sz="1800" dirty="0"/>
           </a:p>
@@ -3639,7 +3639,7 @@
                 <a:latin typeface="Segoe UI"/>
                 <a:cs typeface="Segoe UI"/>
               </a:rPr>
-              <a:t xml:space="preserve">(0, 5)</a:t>
+              <a:t xml:space="preserve">A translation down 2 units</a:t>
             </a:r>
             <a:br>
               <a:rPr lang="en-US" sz="1800" dirty="0">
@@ -3658,7 +3658,7 @@
                 <a:latin typeface="Segoe UI"/>
                 <a:cs typeface="Segoe UI"/>
               </a:rPr>
-              <a:t xml:space="preserve">1. g(x) = 2x − 1 + 6. 2. Combine: −1 + 6 = 5, so g(x) = 2x + 5. 3. b = 5, so the y-intercept is (0, 5): (0, −1) moved up 6.</a:t>
+              <a:t xml:space="preserve">1. The − 2 is outside f(x): it changes every output (y-value). 2. Minus means down: a translation down 2 units.</a:t>
             </a:r>
             <a:endParaRPr lang="en-US" sz="1800" dirty="0"/>
           </a:p>
@@ -4885,7 +4885,7 @@
                 <a:latin typeface="Segoe UI"/>
                 <a:cs typeface="Segoe UI"/>
               </a:rPr>
-              <a:t xml:space="preserve"> · SE p. 280</a:t>
+              <a:t xml:space="preserve"> · SE p. 278</a:t>
             </a:r>
             <a:endParaRPr lang="en-US" sz="1800" dirty="0"/>
           </a:p>
@@ -4929,7 +4929,7 @@
                 <a:latin typeface="Segoe UI"/>
                 <a:cs typeface="Segoe UI"/>
               </a:rPr>
-              <a:t xml:space="preserve">f(x) = x and g(x) = 2f(x) − 5. What is the y-intercept of g(x)?</a:t>
+              <a:t xml:space="preserve">Which function is a reflection of f(x) = x across the x-axis and a vertical dilation by a factor of 2?</a:t>
             </a:r>
             <a:endParaRPr lang="en-US" sz="1800" dirty="0"/>
           </a:p>
@@ -4973,7 +4973,7 @@
                 <a:latin typeface="Segoe UI"/>
                 <a:cs typeface="Segoe UI"/>
               </a:rPr>
-              <a:t xml:space="preserve">(0, −5)</a:t>
+              <a:t xml:space="preserve">g(x) = −2x</a:t>
             </a:r>
             <a:br>
               <a:rPr lang="en-US" sz="1800" dirty="0">
@@ -4992,7 +4992,7 @@
                 <a:latin typeface="Segoe UI"/>
                 <a:cs typeface="Segoe UI"/>
               </a:rPr>
-              <a:t xml:space="preserve">1. Replace f(x) with x: g(x) = 2x − 5. 2. d = −5, so the y-intercept is (0, −5).</a:t>
+              <a:t xml:space="preserve">1. Reflect: a is negative. Factor of 2: |a| = 2. 2. So a = −2 and g(x) = −2x.</a:t>
             </a:r>
             <a:endParaRPr lang="en-US" sz="1800" dirty="0"/>
           </a:p>

</xml_diff>